<commit_message>
feat: HUMAN_REVIEW UI, 학습맵 매칭 개선, L2-B HWP 생성, 디자인 개선
- HUMAN_REVIEW: 3회 반려 문항 교사 승인/반려 API + 프론트엔드 페이지
- 학습맵 매칭: 조사 제거 패치로 40/40 미매핑 문항 재매칭 성공
- L2-B HWP: 문항 포함 HWPML 생성 + S3 저장 + DB 경로 업데이트
- Embedding 에이전트 추가 (OPENAI_API_KEY 없으면 mock 폴백)
- PROD_REVIEW 전이표 수정 (None → DATA 정상 진행)
- UI 디자인: Pretendard 폰트, 에메랄드 악센트, 사이드바 축소/확장
- 렌더링 미리보기 검정 배경 버그 수정 (render-preview 클래스)
</commit_message>
<xml_diff>
--- a/00-1. human 놀이터/출제 마법사 구조.pptx
+++ b/00-1. human 놀이터/출제 마법사 구조.pptx
@@ -7,6 +7,7 @@
   <p:sldIdLst>
     <p:sldId id="257" r:id="rId2"/>
     <p:sldId id="256" r:id="rId3"/>
+    <p:sldId id="258" r:id="rId4"/>
   </p:sldIdLst>
   <p:sldSz cx="12192000" cy="6858000"/>
   <p:notesSz cx="6858000" cy="9144000"/>
@@ -105,6 +106,11 @@
       </a:defRPr>
     </a:lvl9pPr>
   </p:defaultTextStyle>
+  <p:extLst>
+    <p:ext uri="{EFAFB233-063F-42B5-8137-9DF3F51BA10A}">
+      <p15:sldGuideLst xmlns:p15="http://schemas.microsoft.com/office/powerpoint/2012/main"/>
+    </p:ext>
+  </p:extLst>
 </p:presentation>
 </file>
 
@@ -255,7 +261,7 @@
           <a:p>
             <a:fld id="{EEEB743A-7293-4ABF-BBC1-D85B03908227}" type="datetimeFigureOut">
               <a:rPr lang="ko-KR" altLang="en-US" smtClean="0"/>
-              <a:t>2026-04-01</a:t>
+              <a:t>2026-04-02</a:t>
             </a:fld>
             <a:endParaRPr lang="ko-KR" altLang="en-US"/>
           </a:p>
@@ -453,7 +459,7 @@
           <a:p>
             <a:fld id="{EEEB743A-7293-4ABF-BBC1-D85B03908227}" type="datetimeFigureOut">
               <a:rPr lang="ko-KR" altLang="en-US" smtClean="0"/>
-              <a:t>2026-04-01</a:t>
+              <a:t>2026-04-02</a:t>
             </a:fld>
             <a:endParaRPr lang="ko-KR" altLang="en-US"/>
           </a:p>
@@ -661,7 +667,7 @@
           <a:p>
             <a:fld id="{EEEB743A-7293-4ABF-BBC1-D85B03908227}" type="datetimeFigureOut">
               <a:rPr lang="ko-KR" altLang="en-US" smtClean="0"/>
-              <a:t>2026-04-01</a:t>
+              <a:t>2026-04-02</a:t>
             </a:fld>
             <a:endParaRPr lang="ko-KR" altLang="en-US"/>
           </a:p>
@@ -859,7 +865,7 @@
           <a:p>
             <a:fld id="{EEEB743A-7293-4ABF-BBC1-D85B03908227}" type="datetimeFigureOut">
               <a:rPr lang="ko-KR" altLang="en-US" smtClean="0"/>
-              <a:t>2026-04-01</a:t>
+              <a:t>2026-04-02</a:t>
             </a:fld>
             <a:endParaRPr lang="ko-KR" altLang="en-US"/>
           </a:p>
@@ -1134,7 +1140,7 @@
           <a:p>
             <a:fld id="{EEEB743A-7293-4ABF-BBC1-D85B03908227}" type="datetimeFigureOut">
               <a:rPr lang="ko-KR" altLang="en-US" smtClean="0"/>
-              <a:t>2026-04-01</a:t>
+              <a:t>2026-04-02</a:t>
             </a:fld>
             <a:endParaRPr lang="ko-KR" altLang="en-US"/>
           </a:p>
@@ -1399,7 +1405,7 @@
           <a:p>
             <a:fld id="{EEEB743A-7293-4ABF-BBC1-D85B03908227}" type="datetimeFigureOut">
               <a:rPr lang="ko-KR" altLang="en-US" smtClean="0"/>
-              <a:t>2026-04-01</a:t>
+              <a:t>2026-04-02</a:t>
             </a:fld>
             <a:endParaRPr lang="ko-KR" altLang="en-US"/>
           </a:p>
@@ -1811,7 +1817,7 @@
           <a:p>
             <a:fld id="{EEEB743A-7293-4ABF-BBC1-D85B03908227}" type="datetimeFigureOut">
               <a:rPr lang="ko-KR" altLang="en-US" smtClean="0"/>
-              <a:t>2026-04-01</a:t>
+              <a:t>2026-04-02</a:t>
             </a:fld>
             <a:endParaRPr lang="ko-KR" altLang="en-US"/>
           </a:p>
@@ -1952,7 +1958,7 @@
           <a:p>
             <a:fld id="{EEEB743A-7293-4ABF-BBC1-D85B03908227}" type="datetimeFigureOut">
               <a:rPr lang="ko-KR" altLang="en-US" smtClean="0"/>
-              <a:t>2026-04-01</a:t>
+              <a:t>2026-04-02</a:t>
             </a:fld>
             <a:endParaRPr lang="ko-KR" altLang="en-US"/>
           </a:p>
@@ -2065,7 +2071,7 @@
           <a:p>
             <a:fld id="{EEEB743A-7293-4ABF-BBC1-D85B03908227}" type="datetimeFigureOut">
               <a:rPr lang="ko-KR" altLang="en-US" smtClean="0"/>
-              <a:t>2026-04-01</a:t>
+              <a:t>2026-04-02</a:t>
             </a:fld>
             <a:endParaRPr lang="ko-KR" altLang="en-US"/>
           </a:p>
@@ -2376,7 +2382,7 @@
           <a:p>
             <a:fld id="{EEEB743A-7293-4ABF-BBC1-D85B03908227}" type="datetimeFigureOut">
               <a:rPr lang="ko-KR" altLang="en-US" smtClean="0"/>
-              <a:t>2026-04-01</a:t>
+              <a:t>2026-04-02</a:t>
             </a:fld>
             <a:endParaRPr lang="ko-KR" altLang="en-US"/>
           </a:p>
@@ -2664,7 +2670,7 @@
           <a:p>
             <a:fld id="{EEEB743A-7293-4ABF-BBC1-D85B03908227}" type="datetimeFigureOut">
               <a:rPr lang="ko-KR" altLang="en-US" smtClean="0"/>
-              <a:t>2026-04-01</a:t>
+              <a:t>2026-04-02</a:t>
             </a:fld>
             <a:endParaRPr lang="ko-KR" altLang="en-US"/>
           </a:p>
@@ -2905,7 +2911,7 @@
           <a:p>
             <a:fld id="{EEEB743A-7293-4ABF-BBC1-D85B03908227}" type="datetimeFigureOut">
               <a:rPr lang="ko-KR" altLang="en-US" smtClean="0"/>
-              <a:t>2026-04-01</a:t>
+              <a:t>2026-04-02</a:t>
             </a:fld>
             <a:endParaRPr lang="ko-KR" altLang="en-US"/>
           </a:p>
@@ -7897,6 +7903,314 @@
     <p:extLst>
       <p:ext uri="{BB962C8B-B14F-4D97-AF65-F5344CB8AC3E}">
         <p14:creationId xmlns:p14="http://schemas.microsoft.com/office/powerpoint/2010/main" val="181135887"/>
+      </p:ext>
+    </p:extLst>
+  </p:cSld>
+  <p:clrMapOvr>
+    <a:masterClrMapping/>
+  </p:clrMapOvr>
+</p:sld>
+</file>
+
+<file path=ppt/slides/slide3.xml><?xml version="1.0" encoding="utf-8"?>
+<p:sld xmlns:a="http://schemas.openxmlformats.org/drawingml/2006/main" xmlns:r="http://schemas.openxmlformats.org/officeDocument/2006/relationships" xmlns:p="http://schemas.openxmlformats.org/presentationml/2006/main">
+  <p:cSld>
+    <p:spTree>
+      <p:nvGrpSpPr>
+        <p:cNvPr id="1" name=""/>
+        <p:cNvGrpSpPr/>
+        <p:nvPr/>
+      </p:nvGrpSpPr>
+      <p:grpSpPr>
+        <a:xfrm>
+          <a:off x="0" y="0"/>
+          <a:ext cx="0" cy="0"/>
+          <a:chOff x="0" y="0"/>
+          <a:chExt cx="0" cy="0"/>
+        </a:xfrm>
+      </p:grpSpPr>
+      <p:sp>
+        <p:nvSpPr>
+          <p:cNvPr id="2" name="TextBox 1">
+            <a:extLst>
+              <a:ext uri="{FF2B5EF4-FFF2-40B4-BE49-F238E27FC236}">
+                <a16:creationId xmlns:a16="http://schemas.microsoft.com/office/drawing/2014/main" id="{87DB888D-AD5A-BE3F-A3C2-682C2B1F9E22}"/>
+              </a:ext>
+            </a:extLst>
+          </p:cNvPr>
+          <p:cNvSpPr txBox="1"/>
+          <p:nvPr/>
+        </p:nvSpPr>
+        <p:spPr>
+          <a:xfrm>
+            <a:off x="424543" y="404949"/>
+            <a:ext cx="5489003" cy="5544146"/>
+          </a:xfrm>
+          <a:prstGeom prst="rect">
+            <a:avLst/>
+          </a:prstGeom>
+          <a:noFill/>
+        </p:spPr>
+        <p:txBody>
+          <a:bodyPr wrap="none" rtlCol="0">
+            <a:spAutoFit/>
+          </a:bodyPr>
+          <a:lstStyle/>
+          <a:p>
+            <a:pPr marL="342900" indent="-342900">
+              <a:lnSpc>
+                <a:spcPct val="200000"/>
+              </a:lnSpc>
+              <a:buAutoNum type="arabicPeriod"/>
+            </a:pPr>
+            <a:r>
+              <a:rPr lang="ko-KR" altLang="en-US" dirty="0"/>
+              <a:t>기존 </a:t>
+            </a:r>
+            <a:r>
+              <a:rPr lang="en-US" altLang="ko-KR" dirty="0"/>
+              <a:t>CMS </a:t>
+            </a:r>
+            <a:r>
+              <a:rPr lang="ko-KR" altLang="en-US" dirty="0"/>
+              <a:t>분석 </a:t>
+            </a:r>
+            <a:r>
+              <a:rPr lang="en-US" altLang="ko-KR" dirty="0"/>
+              <a:t>_ </a:t>
+            </a:r>
+            <a:r>
+              <a:rPr lang="ko-KR" altLang="en-US" dirty="0"/>
+              <a:t>메타정보 리스트 체크</a:t>
+            </a:r>
+            <a:endParaRPr lang="en-US" altLang="ko-KR" dirty="0"/>
+          </a:p>
+          <a:p>
+            <a:pPr marL="342900" indent="-342900">
+              <a:lnSpc>
+                <a:spcPct val="200000"/>
+              </a:lnSpc>
+              <a:buAutoNum type="arabicPeriod"/>
+            </a:pPr>
+            <a:r>
+              <a:rPr lang="ko-KR" altLang="en-US" dirty="0"/>
+              <a:t>한글 파일 파싱으로 발생할 수 있는 데이터 체크</a:t>
+            </a:r>
+            <a:endParaRPr lang="en-US" altLang="ko-KR" dirty="0"/>
+          </a:p>
+          <a:p>
+            <a:pPr marL="342900" indent="-342900">
+              <a:lnSpc>
+                <a:spcPct val="200000"/>
+              </a:lnSpc>
+              <a:buAutoNum type="arabicPeriod"/>
+            </a:pPr>
+            <a:r>
+              <a:rPr lang="ko-KR" altLang="en-US" dirty="0"/>
+              <a:t>요구사항 분석 </a:t>
+            </a:r>
+            <a:br>
+              <a:rPr lang="en-US" altLang="ko-KR" dirty="0"/>
+            </a:br>
+            <a:r>
+              <a:rPr lang="en-US" altLang="ko-KR" dirty="0"/>
+              <a:t>1) </a:t>
+            </a:r>
+            <a:r>
+              <a:rPr lang="ko-KR" altLang="en-US" dirty="0"/>
+              <a:t>콘텐츠 관리 기능</a:t>
+            </a:r>
+            <a:br>
+              <a:rPr lang="en-US" altLang="ko-KR" dirty="0"/>
+            </a:br>
+            <a:r>
+              <a:rPr lang="en-US" altLang="ko-KR" dirty="0"/>
+              <a:t>	- </a:t>
+            </a:r>
+            <a:r>
+              <a:rPr lang="ko-KR" altLang="en-US" dirty="0"/>
+              <a:t>콘텐츠 등록</a:t>
+            </a:r>
+            <a:r>
+              <a:rPr lang="en-US" altLang="ko-KR" dirty="0"/>
+              <a:t>/</a:t>
+            </a:r>
+            <a:r>
+              <a:rPr lang="ko-KR" altLang="en-US" dirty="0"/>
+              <a:t>수정  </a:t>
+            </a:r>
+            <a:br>
+              <a:rPr lang="en-US" altLang="ko-KR" dirty="0"/>
+            </a:br>
+            <a:r>
+              <a:rPr lang="en-US" altLang="ko-KR" dirty="0"/>
+              <a:t>       - </a:t>
+            </a:r>
+            <a:r>
+              <a:rPr lang="ko-KR" altLang="en-US" dirty="0"/>
+              <a:t>콘텐츠 일괄 등록 </a:t>
+            </a:r>
+            <a:r>
+              <a:rPr lang="en-US" altLang="ko-KR" dirty="0"/>
+              <a:t>/ </a:t>
+            </a:r>
+            <a:r>
+              <a:rPr lang="ko-KR" altLang="en-US" dirty="0"/>
+              <a:t>현황</a:t>
+            </a:r>
+            <a:r>
+              <a:rPr lang="en-US" altLang="ko-KR" dirty="0"/>
+              <a:t>(</a:t>
+            </a:r>
+            <a:r>
+              <a:rPr lang="ko-KR" altLang="en-US" dirty="0"/>
+              <a:t>결과</a:t>
+            </a:r>
+            <a:r>
+              <a:rPr lang="en-US" altLang="ko-KR" dirty="0"/>
+              <a:t>)</a:t>
+            </a:r>
+            <a:r>
+              <a:rPr lang="ko-KR" altLang="en-US" dirty="0"/>
+              <a:t> 체크</a:t>
+            </a:r>
+            <a:br>
+              <a:rPr lang="en-US" altLang="ko-KR" dirty="0"/>
+            </a:br>
+            <a:r>
+              <a:rPr lang="en-US" altLang="ko-KR" dirty="0"/>
+              <a:t>2)</a:t>
+            </a:r>
+            <a:r>
+              <a:rPr lang="ko-KR" altLang="en-US" dirty="0"/>
+              <a:t> 서비스 관리를 위한 메타정보 분석</a:t>
+            </a:r>
+            <a:r>
+              <a:rPr lang="en-US" altLang="ko-KR" dirty="0"/>
+              <a:t>/</a:t>
+            </a:r>
+            <a:r>
+              <a:rPr lang="ko-KR" altLang="en-US" dirty="0"/>
+              <a:t>추가 </a:t>
+            </a:r>
+            <a:br>
+              <a:rPr lang="en-US" altLang="ko-KR" dirty="0"/>
+            </a:br>
+            <a:r>
+              <a:rPr lang="en-US" altLang="ko-KR" dirty="0"/>
+              <a:t>       - </a:t>
+            </a:r>
+            <a:r>
+              <a:rPr lang="ko-KR" altLang="en-US" dirty="0"/>
+              <a:t>프론트 기획 참고  </a:t>
+            </a:r>
+            <a:endParaRPr lang="en-US" altLang="ko-KR" dirty="0"/>
+          </a:p>
+          <a:p>
+            <a:pPr marL="342900" indent="-342900">
+              <a:lnSpc>
+                <a:spcPct val="200000"/>
+              </a:lnSpc>
+              <a:buAutoNum type="arabicPeriod"/>
+            </a:pPr>
+            <a:r>
+              <a:rPr lang="ko-KR" altLang="en-US" dirty="0"/>
+              <a:t>관리자 계정 권한 및 범위 설정</a:t>
+            </a:r>
+            <a:endParaRPr lang="en-US" altLang="ko-KR" dirty="0"/>
+          </a:p>
+          <a:p>
+            <a:pPr marL="342900" indent="-342900">
+              <a:lnSpc>
+                <a:spcPct val="200000"/>
+              </a:lnSpc>
+              <a:buAutoNum type="arabicPeriod"/>
+            </a:pPr>
+            <a:r>
+              <a:rPr lang="ko-KR" altLang="en-US" dirty="0"/>
+              <a:t>정책 설정</a:t>
+            </a:r>
+            <a:endParaRPr lang="en-US" altLang="ko-KR" dirty="0"/>
+          </a:p>
+        </p:txBody>
+      </p:sp>
+      <p:sp>
+        <p:nvSpPr>
+          <p:cNvPr id="3" name="TextBox 2">
+            <a:extLst>
+              <a:ext uri="{FF2B5EF4-FFF2-40B4-BE49-F238E27FC236}">
+                <a16:creationId xmlns:a16="http://schemas.microsoft.com/office/drawing/2014/main" id="{BC458296-7B14-FD75-36C4-EB790272FCC6}"/>
+              </a:ext>
+            </a:extLst>
+          </p:cNvPr>
+          <p:cNvSpPr txBox="1"/>
+          <p:nvPr/>
+        </p:nvSpPr>
+        <p:spPr>
+          <a:xfrm>
+            <a:off x="3516993" y="2570299"/>
+            <a:ext cx="3906839" cy="558166"/>
+          </a:xfrm>
+          <a:prstGeom prst="rect">
+            <a:avLst/>
+          </a:prstGeom>
+          <a:noFill/>
+        </p:spPr>
+        <p:txBody>
+          <a:bodyPr wrap="none" rtlCol="0">
+            <a:spAutoFit/>
+          </a:bodyPr>
+          <a:lstStyle/>
+          <a:p>
+            <a:pPr>
+              <a:lnSpc>
+                <a:spcPct val="200000"/>
+              </a:lnSpc>
+            </a:pPr>
+            <a:r>
+              <a:rPr lang="en-US" altLang="ko-KR" dirty="0">
+                <a:solidFill>
+                  <a:srgbClr val="FF0000"/>
+                </a:solidFill>
+              </a:rPr>
+              <a:t>※</a:t>
+            </a:r>
+            <a:r>
+              <a:rPr lang="ko-KR" altLang="en-US" dirty="0">
+                <a:solidFill>
+                  <a:srgbClr val="FF0000"/>
+                </a:solidFill>
+              </a:rPr>
+              <a:t> </a:t>
+            </a:r>
+            <a:r>
+              <a:rPr lang="ko-KR" altLang="en-US" dirty="0" err="1">
+                <a:solidFill>
+                  <a:srgbClr val="FF0000"/>
+                </a:solidFill>
+              </a:rPr>
+              <a:t>셋트</a:t>
+            </a:r>
+            <a:r>
+              <a:rPr lang="ko-KR" altLang="en-US" dirty="0">
+                <a:solidFill>
+                  <a:srgbClr val="FF0000"/>
+                </a:solidFill>
+              </a:rPr>
+              <a:t> 문항에 대한 처리 검토 필요</a:t>
+            </a:r>
+            <a:endParaRPr lang="en-US" altLang="ko-KR" dirty="0">
+              <a:solidFill>
+                <a:srgbClr val="FF0000"/>
+              </a:solidFill>
+            </a:endParaRPr>
+          </a:p>
+        </p:txBody>
+      </p:sp>
+    </p:spTree>
+    <p:extLst>
+      <p:ext uri="{BB962C8B-B14F-4D97-AF65-F5344CB8AC3E}">
+        <p14:creationId xmlns:p14="http://schemas.microsoft.com/office/powerpoint/2010/main" val="2814201085"/>
       </p:ext>
     </p:extLst>
   </p:cSld>

</xml_diff>